<commit_message>
スライド28枚目: 動画のページに指示文(put both the alphabet soup and the tomato sauce in the basket)を記載
Co-Authored-By: Claude Sonnet 5.5 <noreply@anthropic.com>
</commit_message>
<xml_diff>
--- a/docs/RECAP_STEAM_RLToken.pptx
+++ b/docs/RECAP_STEAM_RLToken.pptx
@@ -26865,14 +26865,86 @@
       </p:sp>
       <p:sp>
         <p:nvSpPr>
-          <p:cNvPr id="4" name="label ベース（smolVLA）"/>
+          <p:cNvPr id="4" name="instruction"/>
           <p:cNvSpPr/>
           <p:nvPr/>
         </p:nvSpPr>
         <p:spPr>
           <a:xfrm>
-            <a:off x="548640" y="960120"/>
-            <a:ext cx="2697480" cy="457200"/>
+            <a:off x="548640" y="914400"/>
+            <a:ext cx="11064240" cy="566928"/>
+          </a:xfrm>
+          <a:prstGeom prst="roundRect">
+            <a:avLst>
+              <a:gd name="adj" fmla="val 12000"/>
+            </a:avLst>
+          </a:prstGeom>
+          <a:solidFill>
+            <a:srgbClr val="E8F1FB"/>
+          </a:solidFill>
+          <a:ln w="12700">
+            <a:solidFill>
+              <a:srgbClr val="0B66C3"/>
+            </a:solidFill>
+          </a:ln>
+        </p:spPr>
+        <p:style>
+          <a:lnRef idx="1">
+            <a:schemeClr val="accent1"/>
+          </a:lnRef>
+          <a:fillRef idx="3">
+            <a:schemeClr val="accent1"/>
+          </a:fillRef>
+          <a:effectRef idx="2">
+            <a:schemeClr val="accent1"/>
+          </a:effectRef>
+          <a:fontRef idx="minor">
+            <a:schemeClr val="lt1"/>
+          </a:fontRef>
+        </p:style>
+        <p:txBody>
+          <a:bodyPr rtlCol="0" anchor="ctr" wrap="square" lIns="73152" rIns="73152" tIns="36576" bIns="36576"/>
+          <a:lstStyle/>
+          <a:p>
+            <a:pPr algn="ctr"/>
+            <a:r>
+              <a:rPr sz="1500" b="1" i="0">
+                <a:solidFill>
+                  <a:srgbClr val="0B66C3"/>
+                </a:solidFill>
+                <a:latin typeface="Yu Gothic"/>
+                <a:ea typeface="Yu Gothic"/>
+                <a:cs typeface="Yu Gothic"/>
+              </a:rPr>
+              <a:t>指示文（全手法で共通）:  "put both the alphabet soup and the tomato sauce in the basket"</a:t>
+            </a:r>
+          </a:p>
+          <a:p>
+            <a:pPr algn="ctr"/>
+            <a:r>
+              <a:rPr sz="1200" b="0" i="0">
+                <a:solidFill>
+                  <a:srgbClr val="595959"/>
+                </a:solidFill>
+                <a:latin typeface="Yu Gothic"/>
+                <a:ea typeface="Yu Gothic"/>
+                <a:cs typeface="Yu Gothic"/>
+              </a:rPr>
+              <a:t>（アルファベットスープの缶とトマトソースの、両方をカゴに入れる。Task 0）</a:t>
+            </a:r>
+          </a:p>
+        </p:txBody>
+      </p:sp>
+      <p:sp>
+        <p:nvSpPr>
+          <p:cNvPr id="5" name="label ベース（smolVLA）"/>
+          <p:cNvSpPr/>
+          <p:nvPr/>
+        </p:nvSpPr>
+        <p:spPr>
+          <a:xfrm>
+            <a:off x="548640" y="1554480"/>
+            <a:ext cx="2423160" cy="411480"/>
           </a:xfrm>
           <a:prstGeom prst="roundRect">
             <a:avLst>
@@ -26921,7 +26993,7 @@
       </p:sp>
       <p:pic>
         <p:nvPicPr>
-          <p:cNvPr id="5" name="video ベース（smolVLA）">
+          <p:cNvPr id="6" name="video ベース（smolVLA）">
             <a:hlinkClick r:id="" action="ppaction://media"/>
           </p:cNvPr>
           <p:cNvPicPr>
@@ -26944,8 +27016,8 @@
         </p:blipFill>
         <p:spPr>
           <a:xfrm>
-            <a:off x="548640" y="1508760"/>
-            <a:ext cx="2697480" cy="2697480"/>
+            <a:off x="548640" y="2011680"/>
+            <a:ext cx="2423160" cy="2423160"/>
           </a:xfrm>
           <a:prstGeom prst="rect">
             <a:avLst/>
@@ -26954,14 +27026,14 @@
       </p:pic>
       <p:sp>
         <p:nvSpPr>
-          <p:cNvPr id="6" name="result ベース（smolVLA）"/>
+          <p:cNvPr id="7" name="result ベース（smolVLA）"/>
           <p:cNvSpPr/>
           <p:nvPr/>
         </p:nvSpPr>
         <p:spPr>
           <a:xfrm>
-            <a:off x="548640" y="4297680"/>
-            <a:ext cx="2697480" cy="914400"/>
+            <a:off x="548640" y="4507992"/>
+            <a:ext cx="2423160" cy="731520"/>
           </a:xfrm>
           <a:prstGeom prst="roundRect">
             <a:avLst>
@@ -26995,7 +27067,7 @@
           <a:p>
             <a:pPr algn="ctr"/>
             <a:r>
-              <a:rPr sz="1800" b="1" i="0">
+              <a:rPr sz="1700" b="1" i="0">
                 <a:solidFill>
                   <a:srgbClr val="FFFFFF"/>
                 </a:solidFill>
@@ -27009,7 +27081,7 @@
           <a:p>
             <a:pPr algn="ctr"/>
             <a:r>
-              <a:rPr sz="1200" b="0" i="0">
+              <a:rPr sz="1100" b="0" i="0">
                 <a:solidFill>
                   <a:srgbClr val="FFFFFF"/>
                 </a:solidFill>
@@ -27024,14 +27096,14 @@
       </p:sp>
       <p:sp>
         <p:nvSpPr>
-          <p:cNvPr id="7" name="TextBox 6"/>
+          <p:cNvPr id="8" name="TextBox 7"/>
           <p:cNvSpPr txBox="1"/>
           <p:nvPr/>
         </p:nvSpPr>
         <p:spPr>
           <a:xfrm>
-            <a:off x="548640" y="5257800"/>
-            <a:ext cx="2697480" cy="320040"/>
+            <a:off x="548640" y="5266944"/>
+            <a:ext cx="2423160" cy="274320"/>
           </a:xfrm>
           <a:prstGeom prst="rect">
             <a:avLst/>
@@ -27065,14 +27137,14 @@
       </p:sp>
       <p:sp>
         <p:nvSpPr>
-          <p:cNvPr id="8" name="label RECAP"/>
+          <p:cNvPr id="9" name="label RECAP"/>
           <p:cNvSpPr/>
           <p:nvPr/>
         </p:nvSpPr>
         <p:spPr>
           <a:xfrm>
-            <a:off x="3337560" y="960120"/>
-            <a:ext cx="2697480" cy="457200"/>
+            <a:off x="3429000" y="1554480"/>
+            <a:ext cx="2423160" cy="411480"/>
           </a:xfrm>
           <a:prstGeom prst="roundRect">
             <a:avLst>
@@ -27121,14 +27193,14 @@
       </p:sp>
       <p:sp>
         <p:nvSpPr>
-          <p:cNvPr id="9" name="placeholder RECAP"/>
+          <p:cNvPr id="10" name="placeholder RECAP"/>
           <p:cNvSpPr/>
           <p:nvPr/>
         </p:nvSpPr>
         <p:spPr>
           <a:xfrm>
-            <a:off x="3337560" y="1508760"/>
-            <a:ext cx="2697480" cy="2697480"/>
+            <a:off x="3429000" y="2011680"/>
+            <a:ext cx="2423160" cy="2423160"/>
           </a:xfrm>
           <a:prstGeom prst="roundRect">
             <a:avLst>
@@ -27193,14 +27265,14 @@
       </p:sp>
       <p:sp>
         <p:nvSpPr>
-          <p:cNvPr id="10" name="result RECAP"/>
+          <p:cNvPr id="11" name="result RECAP"/>
           <p:cNvSpPr/>
           <p:nvPr/>
         </p:nvSpPr>
         <p:spPr>
           <a:xfrm>
-            <a:off x="3337560" y="4297680"/>
-            <a:ext cx="2697480" cy="914400"/>
+            <a:off x="3429000" y="4507992"/>
+            <a:ext cx="2423160" cy="731520"/>
           </a:xfrm>
           <a:prstGeom prst="roundRect">
             <a:avLst>
@@ -27234,7 +27306,7 @@
           <a:p>
             <a:pPr algn="ctr"/>
             <a:r>
-              <a:rPr sz="1800" b="1" i="0">
+              <a:rPr sz="1700" b="1" i="0">
                 <a:solidFill>
                   <a:srgbClr val="FFFFFF"/>
                 </a:solidFill>
@@ -27248,7 +27320,7 @@
           <a:p>
             <a:pPr algn="ctr"/>
             <a:r>
-              <a:rPr sz="1200" b="0" i="0">
+              <a:rPr sz="1100" b="0" i="0">
                 <a:solidFill>
                   <a:srgbClr val="FFFFFF"/>
                 </a:solidFill>
@@ -27263,14 +27335,14 @@
       </p:sp>
       <p:sp>
         <p:nvSpPr>
-          <p:cNvPr id="11" name="TextBox 10"/>
+          <p:cNvPr id="12" name="TextBox 11"/>
           <p:cNvSpPr txBox="1"/>
           <p:nvPr/>
         </p:nvSpPr>
         <p:spPr>
           <a:xfrm>
-            <a:off x="3337560" y="5257800"/>
-            <a:ext cx="2697480" cy="320040"/>
+            <a:off x="3429000" y="5266944"/>
+            <a:ext cx="2423160" cy="274320"/>
           </a:xfrm>
           <a:prstGeom prst="rect">
             <a:avLst/>
@@ -27304,14 +27376,14 @@
       </p:sp>
       <p:sp>
         <p:nvSpPr>
-          <p:cNvPr id="12" name="label STEAM"/>
+          <p:cNvPr id="13" name="label STEAM"/>
           <p:cNvSpPr/>
           <p:nvPr/>
         </p:nvSpPr>
         <p:spPr>
           <a:xfrm>
-            <a:off x="6126479" y="960120"/>
-            <a:ext cx="2697480" cy="457200"/>
+            <a:off x="6309359" y="1554480"/>
+            <a:ext cx="2423160" cy="411480"/>
           </a:xfrm>
           <a:prstGeom prst="roundRect">
             <a:avLst>
@@ -27360,14 +27432,14 @@
       </p:sp>
       <p:sp>
         <p:nvSpPr>
-          <p:cNvPr id="13" name="placeholder STEAM"/>
+          <p:cNvPr id="14" name="placeholder STEAM"/>
           <p:cNvSpPr/>
           <p:nvPr/>
         </p:nvSpPr>
         <p:spPr>
           <a:xfrm>
-            <a:off x="6126479" y="1508760"/>
-            <a:ext cx="2697480" cy="2697480"/>
+            <a:off x="6309359" y="2011680"/>
+            <a:ext cx="2423160" cy="2423160"/>
           </a:xfrm>
           <a:prstGeom prst="roundRect">
             <a:avLst>
@@ -27432,14 +27504,14 @@
       </p:sp>
       <p:sp>
         <p:nvSpPr>
-          <p:cNvPr id="14" name="result STEAM"/>
+          <p:cNvPr id="15" name="result STEAM"/>
           <p:cNvSpPr/>
           <p:nvPr/>
         </p:nvSpPr>
         <p:spPr>
           <a:xfrm>
-            <a:off x="6126479" y="4297680"/>
-            <a:ext cx="2697480" cy="914400"/>
+            <a:off x="6309359" y="4507992"/>
+            <a:ext cx="2423160" cy="731520"/>
           </a:xfrm>
           <a:prstGeom prst="roundRect">
             <a:avLst>
@@ -27473,7 +27545,7 @@
           <a:p>
             <a:pPr algn="ctr"/>
             <a:r>
-              <a:rPr sz="1800" b="1" i="0">
+              <a:rPr sz="1700" b="1" i="0">
                 <a:solidFill>
                   <a:srgbClr val="FFFFFF"/>
                 </a:solidFill>
@@ -27487,7 +27559,7 @@
           <a:p>
             <a:pPr algn="ctr"/>
             <a:r>
-              <a:rPr sz="1200" b="0" i="0">
+              <a:rPr sz="1100" b="0" i="0">
                 <a:solidFill>
                   <a:srgbClr val="FFFFFF"/>
                 </a:solidFill>
@@ -27502,14 +27574,14 @@
       </p:sp>
       <p:sp>
         <p:nvSpPr>
-          <p:cNvPr id="15" name="TextBox 14"/>
+          <p:cNvPr id="16" name="TextBox 15"/>
           <p:cNvSpPr txBox="1"/>
           <p:nvPr/>
         </p:nvSpPr>
         <p:spPr>
           <a:xfrm>
-            <a:off x="6126479" y="5257800"/>
-            <a:ext cx="2697480" cy="320040"/>
+            <a:off x="6309359" y="5266944"/>
+            <a:ext cx="2423160" cy="274320"/>
           </a:xfrm>
           <a:prstGeom prst="rect">
             <a:avLst/>
@@ -27543,14 +27615,14 @@
       </p:sp>
       <p:sp>
         <p:nvSpPr>
-          <p:cNvPr id="16" name="label RL Token（最良）"/>
+          <p:cNvPr id="17" name="label RL Token（最良）"/>
           <p:cNvSpPr/>
           <p:nvPr/>
         </p:nvSpPr>
         <p:spPr>
           <a:xfrm>
-            <a:off x="8915399" y="960120"/>
-            <a:ext cx="2697480" cy="457200"/>
+            <a:off x="9189719" y="1554480"/>
+            <a:ext cx="2423160" cy="411480"/>
           </a:xfrm>
           <a:prstGeom prst="roundRect">
             <a:avLst>
@@ -27599,7 +27671,7 @@
       </p:sp>
       <p:pic>
         <p:nvPicPr>
-          <p:cNvPr id="17" name="video RL Token（最良）">
+          <p:cNvPr id="18" name="video RL Token（最良）">
             <a:hlinkClick r:id="" action="ppaction://media"/>
           </p:cNvPr>
           <p:cNvPicPr>
@@ -27622,8 +27694,8 @@
         </p:blipFill>
         <p:spPr>
           <a:xfrm>
-            <a:off x="8915399" y="1508760"/>
-            <a:ext cx="2697480" cy="2697480"/>
+            <a:off x="9189719" y="2011680"/>
+            <a:ext cx="2423160" cy="2423160"/>
           </a:xfrm>
           <a:prstGeom prst="rect">
             <a:avLst/>
@@ -27632,14 +27704,14 @@
       </p:pic>
       <p:sp>
         <p:nvSpPr>
-          <p:cNvPr id="18" name="result RL Token（最良）"/>
+          <p:cNvPr id="19" name="result RL Token（最良）"/>
           <p:cNvSpPr/>
           <p:nvPr/>
         </p:nvSpPr>
         <p:spPr>
           <a:xfrm>
-            <a:off x="8915399" y="4297680"/>
-            <a:ext cx="2697480" cy="914400"/>
+            <a:off x="9189719" y="4507992"/>
+            <a:ext cx="2423160" cy="731520"/>
           </a:xfrm>
           <a:prstGeom prst="roundRect">
             <a:avLst>
@@ -27673,7 +27745,7 @@
           <a:p>
             <a:pPr algn="ctr"/>
             <a:r>
-              <a:rPr sz="1800" b="1" i="0">
+              <a:rPr sz="1700" b="1" i="0">
                 <a:solidFill>
                   <a:srgbClr val="FFFFFF"/>
                 </a:solidFill>
@@ -27687,7 +27759,7 @@
           <a:p>
             <a:pPr algn="ctr"/>
             <a:r>
-              <a:rPr sz="1200" b="0" i="0">
+              <a:rPr sz="1100" b="0" i="0">
                 <a:solidFill>
                   <a:srgbClr val="FFFFFF"/>
                 </a:solidFill>
@@ -27702,14 +27774,14 @@
       </p:sp>
       <p:sp>
         <p:nvSpPr>
-          <p:cNvPr id="19" name="TextBox 18"/>
+          <p:cNvPr id="20" name="TextBox 19"/>
           <p:cNvSpPr txBox="1"/>
           <p:nvPr/>
         </p:nvSpPr>
         <p:spPr>
           <a:xfrm>
-            <a:off x="8915399" y="5257800"/>
-            <a:ext cx="2697480" cy="320040"/>
+            <a:off x="9189719" y="5266944"/>
+            <a:ext cx="2423160" cy="274320"/>
           </a:xfrm>
           <a:prstGeom prst="rect">
             <a:avLst/>
@@ -27743,7 +27815,7 @@
       </p:sp>
       <p:sp>
         <p:nvSpPr>
-          <p:cNvPr id="20" name="TextBox 19"/>
+          <p:cNvPr id="21" name="TextBox 20"/>
           <p:cNvSpPr txBox="1"/>
           <p:nvPr/>
         </p:nvSpPr>
@@ -27784,7 +27856,7 @@
       </p:sp>
       <p:sp>
         <p:nvSpPr>
-          <p:cNvPr id="21" name="key point"/>
+          <p:cNvPr id="22" name="key point"/>
           <p:cNvSpPr/>
           <p:nvPr/>
         </p:nvSpPr>
@@ -27858,7 +27930,7 @@
                   </p:stCondLst>
                 </p:cTn>
                 <p:tgtEl>
-                  <p:spTgt spid="5"/>
+                  <p:spTgt spid="6"/>
                 </p:tgtEl>
               </p:cMediaNode>
             </p:video>
@@ -27870,7 +27942,7 @@
                   </p:stCondLst>
                 </p:cTn>
                 <p:tgtEl>
-                  <p:spTgt spid="17"/>
+                  <p:spTgt spid="18"/>
                 </p:tgtEl>
               </p:cMediaNode>
             </p:video>

</xml_diff>

<commit_message>
スライド: GPUを確定(RECAPはRTX 6000 Ada、他はA5000)、RL Tokenのバッチサイズを追記、RL Tokenの最良をH(0.74)に修正(results/rlt_libero10_task0_experiments.mdに合わせた)
Co-Authored-By: Claude Sonnet 5.5 <noreply@anthropic.com>
</commit_message>
<xml_diff>
--- a/docs/RECAP_STEAM_RLToken.pptx
+++ b/docs/RECAP_STEAM_RLToken.pptx
@@ -494,7 +494,7 @@
                   <c:v>52.0</c:v>
                 </c:pt>
                 <c:pt idx="5">
-                  <c:v>68.0</c:v>
+                  <c:v>74.0</c:v>
                 </c:pt>
               </c:numCache>
             </c:numRef>
@@ -2402,7 +2402,7 @@
           <a:lstStyle/>
           <a:p>
             <a:r>
-              <a:t>同じ初期状態 14 での比較。ベースと RL Token の動画は wandb: https://wandb.ai/junhand/libero_RL/runs/w3vkksd0（run 名 demo-init14-base-fail-vs-rlt-success）。RECAP と STEAM は準備中。RECAP と STEAM の評価では、指示文の後に改行して Advantage: positive の札を付ける。【発表者向け】RECAP の 0.50 と STEAM の 0.52 は、advantage プロンプトなしで評価した最良値（プロンプトありは RECAP 0.48、STEAM 0.42）。</a:t>
+              <a:t>同じ初期状態 14 での比較。ベースと RL Token の動画は wandb: https://wandb.ai/junhand/libero_RL/runs/w3vkksd0（run 名 demo-init14-base-fail-vs-rlt-success）。RL Token の動画は H（1 つ目は G の actor、2 つ目は専用 actor）。RECAP と STEAM は準備中。RECAP と STEAM の評価では、指示文の後に改行して Advantage: positive の札を付ける。【発表者向け】RECAP の 0.50 と STEAM の 0.52 は、advantage プロンプトなしで評価した最良値（プロンプトありは RECAP 0.48、STEAM 0.42）。</a:t>
             </a:r>
           </a:p>
         </p:txBody>
@@ -2472,7 +2472,7 @@
           <a:lstStyle/>
           <a:p>
             <a:r>
-              <a:t>実測値（TensorBoard と実行ログ）。GPU は、ログに名前が残っているものだけを記載。</a:t>
+              <a:t>実測値（TensorBoard と実行ログ）。GPU は、RECAP が RTX 6000 Ada、それ以外が RTX A5000。</a:t>
             </a:r>
           </a:p>
         </p:txBody>
@@ -12504,7 +12504,7 @@
                 <a:ea typeface="Yu Gothic"/>
                 <a:cs typeface="Yu Gothic"/>
               </a:rPr>
-              <a:t>）</a:t>
+              <a:t>、RTX 6000 Ada 48GB）</a:t>
             </a:r>
           </a:p>
           <a:p>
@@ -18209,7 +18209,7 @@
                 <a:ea typeface="Yu Gothic"/>
                 <a:cs typeface="Yu Gothic"/>
               </a:rPr>
-              <a:t>RL Token が 0.68</a:t>
+              <a:t>RL Token が 0.74</a:t>
             </a:r>
             <a:r>
               <a:rPr sz="1500" b="0" i="0">
@@ -25564,7 +25564,7 @@
                 <a:ea typeface="Yu Gothic"/>
                 <a:cs typeface="Yu Gothic"/>
               </a:rPr>
-              <a:t>6,000 step、約 25 分</a:t>
+              <a:t>6,000 step、バッチ 64、約 25 分</a:t>
             </a:r>
             <a:r>
               <a:rPr sz="1600" b="0" i="0">
@@ -25575,7 +25575,7 @@
                 <a:ea typeface="Yu Gothic"/>
                 <a:cs typeface="Yu Gothic"/>
               </a:rPr>
-              <a:t>）。再構成の val MSE は 0.073（平均を出す基準は 0.269）</a:t>
+              <a:t>、RTX A5000）。再構成の val MSE は 0.073（平均を出す基準は 0.269）</a:t>
             </a:r>
           </a:p>
           <a:p>
@@ -25616,7 +25616,7 @@
                 <a:ea typeface="Yu Gothic"/>
                 <a:cs typeface="Yu Gothic"/>
               </a:rPr>
-              <a:t>750 エポック、約 8.2 時間</a:t>
+              <a:t>750 エポック、バッチ 512、約 8.2 時間</a:t>
             </a:r>
             <a:r>
               <a:rPr sz="1600" b="0" i="0">
@@ -25657,7 +25657,7 @@
                 <a:ea typeface="Yu Gothic"/>
                 <a:cs typeface="Yu Gothic"/>
               </a:rPr>
-              <a:t>: 残る失敗は 2 つ目の把持が最大 → 2 つ目専用の actor を、空振り（何も挟まずに閉じる）への罰 −0.2 つきで学習（1 つ目は Step3 の actor を固定。</a:t>
+              <a:t>: 残る失敗は 2 つ目の把持が最大 → 2 つ目専用の actor を、初期値なしで学習（1 つ目は Step3 の actor を固定。</a:t>
             </a:r>
             <a:r>
               <a:rPr sz="1600" b="1" i="0">
@@ -25668,7 +25668,7 @@
                 <a:ea typeface="Yu Gothic"/>
                 <a:cs typeface="Yu Gothic"/>
               </a:rPr>
-              <a:t>400 エポック、5.4 時間</a:t>
+              <a:t>400 エポック、バッチ 512、約 5.5 時間</a:t>
             </a:r>
             <a:r>
               <a:rPr sz="1600" b="0" i="0">
@@ -25679,7 +25679,7 @@
                 <a:ea typeface="Yu Gothic"/>
                 <a:cs typeface="Yu Gothic"/>
               </a:rPr>
-              <a:t>、RTX A5000）</a:t>
+              <a:t>、RTX A5000）。空振りへの罰 −0.2 を加えると 0.68 で、効果は確認できなかった</a:t>
             </a:r>
           </a:p>
           <a:p>
@@ -25720,7 +25720,7 @@
                 <a:ea typeface="Yu Gothic"/>
                 <a:cs typeface="Yu Gothic"/>
               </a:rPr>
-              <a:t>0.68</a:t>
+              <a:t>0.74</a:t>
             </a:r>
             <a:r>
               <a:rPr sz="1600" b="0" i="0">
@@ -25731,7 +25731,7 @@
                 <a:ea typeface="Yu Gothic"/>
                 <a:cs typeface="Yu Gothic"/>
               </a:rPr>
-              <a:t>（最良。VLA のみ 0.46、1 つ目だけ RL 0.62、2 局面 0.66）。2 つ目を VLA に任せると 0.60。actor の重みは約 5 MB</a:t>
+              <a:t>（最良。3 つの評価シードの平均は 0.71）。VLA のみ 0.46、1 つ目だけ RL 0.62、2 つ目を VLA に任せる 0.68。actor の重みは約 5 MB</a:t>
             </a:r>
           </a:p>
         </p:txBody>
@@ -25789,7 +25789,7 @@
                 <a:ea typeface="Yu Gothic"/>
                 <a:cs typeface="Yu Gothic"/>
               </a:rPr>
-              <a:t>→ 凍結した VLA の上の小さな actor-critic だけで、success_once が 0.46 → 0.68 に向上した</a:t>
+              <a:t>→ 凍結した VLA の上の小さな actor-critic だけで、success_once が 0.46 → 0.74 に向上した</a:t>
             </a:r>
           </a:p>
         </p:txBody>
@@ -26595,7 +26595,7 @@
                           <a:ea typeface="Yu Gothic"/>
                           <a:cs typeface="Yu Gothic"/>
                         </a:rPr>
-                        <a:t>68.0%</a:t>
+                        <a:t>74.0%</a:t>
                       </a:r>
                     </a:p>
                   </a:txBody>
@@ -26620,7 +26620,7 @@
                           <a:ea typeface="Yu Gothic"/>
                           <a:cs typeface="Yu Gothic"/>
                         </a:rPr>
-                        <a:t>+28.0 pt</a:t>
+                        <a:t>+34.0 pt</a:t>
                       </a:r>
                     </a:p>
                   </a:txBody>
@@ -26767,7 +26767,7 @@
                 <a:ea typeface="Yu Gothic"/>
                 <a:cs typeface="Yu Gothic"/>
               </a:rPr>
-              <a:t>→ smolVLA では RL Token が最良（40% → 68%）。RECAP・STEAM は途中段階で、差は有意とは言えない</a:t>
+              <a:t>→ smolVLA では RL Token が最良（40% → 74%）。RECAP・STEAM は途中段階で、差は有意とは言えない</a:t>
             </a:r>
           </a:p>
         </p:txBody>
@@ -27844,7 +27844,7 @@
                 <a:ea typeface="Yu Gothic"/>
                 <a:cs typeface="Yu Gothic"/>
               </a:rPr>
-              <a:t>success_once 0.68</a:t>
+              <a:t>success_once 0.74</a:t>
             </a:r>
           </a:p>
         </p:txBody>
@@ -28115,11 +28115,11 @@
               </a:tblPr>
               <a:tblGrid>
                 <a:gridCol w="914400"/>
-                <a:gridCol w="2148840"/>
-                <a:gridCol w="2606040"/>
+                <a:gridCol w="2103120"/>
+                <a:gridCol w="2377440"/>
                 <a:gridCol w="731520"/>
-                <a:gridCol w="2468880"/>
-                <a:gridCol w="2194560"/>
+                <a:gridCol w="2926080"/>
+                <a:gridCol w="2011680"/>
               </a:tblGrid>
               <a:tr h="384048">
                 <a:tc>
@@ -28551,7 +28551,7 @@
                           <a:ea typeface="Yu Gothic"/>
                           <a:cs typeface="Yu Gothic"/>
                         </a:rPr>
-                        <a:t>記録なし</a:t>
+                        <a:t>RTX 6000 Ada（48GB）</a:t>
                       </a:r>
                     </a:p>
                   </a:txBody>
@@ -29238,7 +29238,7 @@
                           <a:ea typeface="Yu Gothic"/>
                           <a:cs typeface="Yu Gothic"/>
                         </a:rPr>
-                        <a:t>—</a:t>
+                        <a:t>64</a:t>
                       </a:r>
                     </a:p>
                   </a:txBody>
@@ -29286,7 +29286,7 @@
                           <a:ea typeface="Yu Gothic"/>
                           <a:cs typeface="Yu Gothic"/>
                         </a:rPr>
-                        <a:t>記録なし</a:t>
+                        <a:t>RTX A5000（24GB）</a:t>
                       </a:r>
                     </a:p>
                   </a:txBody>
@@ -29385,7 +29385,7 @@
                           <a:ea typeface="Yu Gothic"/>
                           <a:cs typeface="Yu Gothic"/>
                         </a:rPr>
-                        <a:t>—</a:t>
+                        <a:t>512</a:t>
                       </a:r>
                     </a:p>
                   </a:txBody>
@@ -29507,7 +29507,7 @@
                           <a:ea typeface="Yu Gothic"/>
                           <a:cs typeface="Yu Gothic"/>
                         </a:rPr>
-                        <a:t>400 エポック（更新 約 7.2 万回）</a:t>
+                        <a:t>400 エポック</a:t>
                       </a:r>
                     </a:p>
                   </a:txBody>
@@ -29532,7 +29532,7 @@
                           <a:ea typeface="Yu Gothic"/>
                           <a:cs typeface="Yu Gothic"/>
                         </a:rPr>
-                        <a:t>—</a:t>
+                        <a:t>512</a:t>
                       </a:r>
                     </a:p>
                   </a:txBody>
@@ -29556,7 +29556,7 @@
                           <a:ea typeface="Yu Gothic"/>
                           <a:cs typeface="Yu Gothic"/>
                         </a:rPr>
-                        <a:t>5.4 時間（約 49 秒/エポック）</a:t>
+                        <a:t>約 5.5 時間（約 49 秒/エポック）</a:t>
                       </a:r>
                     </a:p>
                   </a:txBody>
@@ -29631,7 +29631,7 @@
                 <a:ea typeface="Yu Gothic"/>
                 <a:cs typeface="Yu Gothic"/>
               </a:rPr>
-              <a:t>バッチは global batch。RL Token の 1 エポック = 3 環境のロールアウトと更新。RECAP の advantage は、merged（175.8 万フレーム）のうち 62.3 万サンプル分。「記録なし」は、ログに GPU 名がない</a:t>
+              <a:t>バッチは global batch（RL Token の Stage 2 は micro 128）。RL Token の 1 エポック = 3 環境のロールアウトと更新。RECAP の advantage は、merged（175.8 万フレーム）のうち 62.3 万サンプル分</a:t>
             </a:r>
           </a:p>
         </p:txBody>
@@ -31068,7 +31068,7 @@
                           <a:ea typeface="Yu Gothic"/>
                           <a:cs typeface="Yu Gothic"/>
                         </a:rPr>
-                        <a:t>軽量（約 5 MB）で、約 5 時間で学習。success_once 0.46 → 0.68</a:t>
+                        <a:t>軽量（約 5 MB）で、約 5 時間で学習。success_once 0.46 → 0.74</a:t>
                       </a:r>
                     </a:p>
                   </a:txBody>
@@ -31412,7 +31412,7 @@
                 <a:ea typeface="Yu Gothic"/>
                 <a:cs typeface="Yu Gothic"/>
               </a:rPr>
-              <a:t>（0.40 → 0.68）</a:t>
+              <a:t>（0.40 → 0.74）</a:t>
             </a:r>
           </a:p>
           <a:p>
@@ -31871,7 +31871,7 @@
                 <a:ea typeface="Yu Gothic"/>
                 <a:cs typeface="Yu Gothic"/>
               </a:rPr>
-              <a:t>0.68</a:t>
+              <a:t>0.74</a:t>
             </a:r>
           </a:p>
           <a:p>
@@ -31943,7 +31943,7 @@
                 <a:ea typeface="Yu Gothic"/>
                 <a:cs typeface="Yu Gothic"/>
               </a:rPr>
-              <a:t>→ 最良は RL Token（0.68）。RECAP・STEAM は、学習を進めて、同じ条件で再評価する</a:t>
+              <a:t>→ 最良は RL Token（0.74）。RECAP・STEAM は、学習を進めて、同じ条件で再評価する</a:t>
             </a:r>
           </a:p>
         </p:txBody>
@@ -34296,7 +34296,7 @@
                 <a:ea typeface="Yu Gothic"/>
                 <a:cs typeface="Yu Gothic"/>
               </a:rPr>
-              <a:t>: 主に </a:t>
+              <a:t>: RECAP は </a:t>
             </a:r>
             <a:r>
               <a:rPr sz="1700" b="1" i="0">
@@ -34307,18 +34307,29 @@
                 <a:ea typeface="Yu Gothic"/>
                 <a:cs typeface="Yu Gothic"/>
               </a:rPr>
+              <a:t>RTX 6000 Ada（48GB）</a:t>
+            </a:r>
+            <a:r>
+              <a:rPr sz="1700" b="0" i="0">
+                <a:solidFill>
+                  <a:srgbClr val="1A1A1A"/>
+                </a:solidFill>
+                <a:latin typeface="Yu Gothic"/>
+                <a:ea typeface="Yu Gothic"/>
+                <a:cs typeface="Yu Gothic"/>
+              </a:rPr>
+              <a:t>、それ以外は </a:t>
+            </a:r>
+            <a:r>
+              <a:rPr sz="1700" b="1" i="0">
+                <a:solidFill>
+                  <a:srgbClr val="1A1A1A"/>
+                </a:solidFill>
+                <a:latin typeface="Yu Gothic"/>
+                <a:ea typeface="Yu Gothic"/>
+                <a:cs typeface="Yu Gothic"/>
+              </a:rPr>
               <a:t>RTX A5000（24GB）</a:t>
-            </a:r>
-            <a:r>
-              <a:rPr sz="1700" b="0" i="0">
-                <a:solidFill>
-                  <a:srgbClr val="1A1A1A"/>
-                </a:solidFill>
-                <a:latin typeface="Yu Gothic"/>
-                <a:ea typeface="Yu Gothic"/>
-                <a:cs typeface="Yu Gothic"/>
-              </a:rPr>
-              <a:t>。RECAP の価値モデルと Step4 は RTX 6000 Ada（48GB）</a:t>
             </a:r>
           </a:p>
         </p:txBody>

</xml_diff>